<commit_message>
docs: publish latest docs
</commit_message>
<xml_diff>
--- a/latest/macos-app-install/macos-app-install-slides.pptx
+++ b/latest/macos-app-install/macos-app-install-slides.pptx
@@ -5,14 +5,13 @@
     <p:sldMasterId xmlns:r="http://schemas.openxmlformats.org/officeDocument/2006/relationships" id="2147483648" r:id="rId1"/>
   </p:sldMasterIdLst>
   <p:sldIdLst>
-    <p:sldId id="256" r:id="Rd3e5b2fdb472422d"/>
-    <p:sldId id="257" r:id="Rff33c7425b5a425b"/>
-    <p:sldId id="258" r:id="Rf1bd0c89162141f9"/>
-    <p:sldId id="259" r:id="Rcff129f86a28425f"/>
-    <p:sldId id="260" r:id="R500b48141a5c463d"/>
-    <p:sldId id="261" r:id="Ra72dd777175a4dda"/>
-    <p:sldId id="262" r:id="R6ad79157f1084357"/>
-    <p:sldId id="263" r:id="R7485ff926dc74233"/>
+    <p:sldId id="256" r:id="R7b2b336e2e994224"/>
+    <p:sldId id="257" r:id="R240e2a64294d4db0"/>
+    <p:sldId id="258" r:id="R63fc0f16b00445f6"/>
+    <p:sldId id="259" r:id="R6ad162ce242d41fa"/>
+    <p:sldId id="260" r:id="R714afbb3b5ae49c6"/>
+    <p:sldId id="261" r:id="R1eebbe5b81bd448f"/>
+    <p:sldId id="262" r:id="R14002d8a67e048d4"/>
   </p:sldIdLst>
   <p:sldSz cx="12192000" cy="6858000" type="screen16x9"/>
   <p:notesSz cx="6858000" cy="9144000"/>
@@ -328,7 +327,7 @@
           <p:nvPr/>
         </p:nvPicPr>
         <p:blipFill>
-          <a:blip xmlns:r="http://schemas.openxmlformats.org/officeDocument/2006/relationships" xmlns:a="http://schemas.openxmlformats.org/drawingml/2006/main" r:embed="R065c566ee9bf4e88"/>
+          <a:blip xmlns:r="http://schemas.openxmlformats.org/officeDocument/2006/relationships" xmlns:a="http://schemas.openxmlformats.org/drawingml/2006/main" r:embed="Rc584bbeba6c94c3c"/>
           <a:stretch xmlns:a="http://schemas.openxmlformats.org/drawingml/2006/main">
             <a:fillRect/>
           </a:stretch>
@@ -367,7 +366,7 @@
           <p:nvPr/>
         </p:nvPicPr>
         <p:blipFill>
-          <a:blip xmlns:r="http://schemas.openxmlformats.org/officeDocument/2006/relationships" xmlns:a="http://schemas.openxmlformats.org/drawingml/2006/main" r:embed="R4ad27e8053da4d67"/>
+          <a:blip xmlns:r="http://schemas.openxmlformats.org/officeDocument/2006/relationships" xmlns:a="http://schemas.openxmlformats.org/drawingml/2006/main" r:embed="Rb4e39f9e0a364f0f"/>
           <a:stretch xmlns:a="http://schemas.openxmlformats.org/drawingml/2006/main">
             <a:fillRect/>
           </a:stretch>
@@ -406,7 +405,7 @@
           <p:nvPr/>
         </p:nvPicPr>
         <p:blipFill>
-          <a:blip xmlns:r="http://schemas.openxmlformats.org/officeDocument/2006/relationships" xmlns:a="http://schemas.openxmlformats.org/drawingml/2006/main" r:embed="R551b4eec7fed4b11"/>
+          <a:blip xmlns:r="http://schemas.openxmlformats.org/officeDocument/2006/relationships" xmlns:a="http://schemas.openxmlformats.org/drawingml/2006/main" r:embed="R54d589a6d3264fd5"/>
           <a:stretch xmlns:a="http://schemas.openxmlformats.org/drawingml/2006/main">
             <a:fillRect/>
           </a:stretch>
@@ -445,7 +444,7 @@
           <p:nvPr/>
         </p:nvPicPr>
         <p:blipFill>
-          <a:blip xmlns:r="http://schemas.openxmlformats.org/officeDocument/2006/relationships" xmlns:a="http://schemas.openxmlformats.org/drawingml/2006/main" r:embed="Re29927f1989c4c32"/>
+          <a:blip xmlns:r="http://schemas.openxmlformats.org/officeDocument/2006/relationships" xmlns:a="http://schemas.openxmlformats.org/drawingml/2006/main" r:embed="R78bd9fbfacae40f1"/>
           <a:stretch xmlns:a="http://schemas.openxmlformats.org/drawingml/2006/main">
             <a:fillRect/>
           </a:stretch>
@@ -484,7 +483,7 @@
           <p:nvPr/>
         </p:nvPicPr>
         <p:blipFill>
-          <a:blip xmlns:r="http://schemas.openxmlformats.org/officeDocument/2006/relationships" xmlns:a="http://schemas.openxmlformats.org/drawingml/2006/main" r:embed="Rd1d88eb62421453f"/>
+          <a:blip xmlns:r="http://schemas.openxmlformats.org/officeDocument/2006/relationships" xmlns:a="http://schemas.openxmlformats.org/drawingml/2006/main" r:embed="Rc9cc803e0c224e14"/>
           <a:stretch xmlns:a="http://schemas.openxmlformats.org/drawingml/2006/main">
             <a:fillRect/>
           </a:stretch>
@@ -523,7 +522,7 @@
           <p:nvPr/>
         </p:nvPicPr>
         <p:blipFill>
-          <a:blip xmlns:r="http://schemas.openxmlformats.org/officeDocument/2006/relationships" xmlns:a="http://schemas.openxmlformats.org/drawingml/2006/main" r:embed="Rd4130d622c7d4967"/>
+          <a:blip xmlns:r="http://schemas.openxmlformats.org/officeDocument/2006/relationships" xmlns:a="http://schemas.openxmlformats.org/drawingml/2006/main" r:embed="R8b16ea17aa4d4f79"/>
           <a:stretch xmlns:a="http://schemas.openxmlformats.org/drawingml/2006/main">
             <a:fillRect/>
           </a:stretch>
@@ -562,46 +561,7 @@
           <p:nvPr/>
         </p:nvPicPr>
         <p:blipFill>
-          <a:blip xmlns:r="http://schemas.openxmlformats.org/officeDocument/2006/relationships" xmlns:a="http://schemas.openxmlformats.org/drawingml/2006/main" r:embed="R3a7e8243763741ab"/>
-          <a:stretch xmlns:a="http://schemas.openxmlformats.org/drawingml/2006/main">
-            <a:fillRect/>
-          </a:stretch>
-        </p:blipFill>
-        <p:spPr>
-          <a:xfrm xmlns:a="http://schemas.openxmlformats.org/drawingml/2006/main">
-            <a:off x="0" y="0"/>
-            <a:ext cx="12192000" cy="6858000"/>
-          </a:xfrm>
-          <a:prstGeom xmlns:a="http://schemas.openxmlformats.org/drawingml/2006/main" prst="rect">
-            <a:avLst/>
-          </a:prstGeom>
-        </p:spPr>
-      </p:pic>
-    </p:spTree>
-  </p:cSld>
-</p:sld>
-</file>
-
-<file path=ppt/slides/slide8.xml><?xml version="1.0" encoding="utf-8"?>
-<p:sld xmlns:p="http://schemas.openxmlformats.org/presentationml/2006/main">
-  <p:cSld name="Slide 8">
-    <p:spTree>
-      <p:nvGrpSpPr>
-        <p:cNvPr id="1" name=""/>
-        <p:cNvGrpSpPr/>
-        <p:nvPr/>
-      </p:nvGrpSpPr>
-      <p:grpSpPr/>
-      <p:pic>
-        <p:nvPicPr>
-          <p:cNvPr id="100007" name="Rendered page 8" descr="Rendered static page 8"/>
-          <p:cNvPicPr>
-            <a:picLocks xmlns:a="http://schemas.openxmlformats.org/drawingml/2006/main" noChangeAspect="1"/>
-          </p:cNvPicPr>
-          <p:nvPr/>
-        </p:nvPicPr>
-        <p:blipFill>
-          <a:blip xmlns:r="http://schemas.openxmlformats.org/officeDocument/2006/relationships" xmlns:a="http://schemas.openxmlformats.org/drawingml/2006/main" r:embed="R7604b2c23c874c29"/>
+          <a:blip xmlns:r="http://schemas.openxmlformats.org/officeDocument/2006/relationships" xmlns:a="http://schemas.openxmlformats.org/drawingml/2006/main" r:embed="R773594c1400448bf"/>
           <a:stretch xmlns:a="http://schemas.openxmlformats.org/drawingml/2006/main">
             <a:fillRect/>
           </a:stretch>

</xml_diff>